<commit_message>
docs: embed deployed Streamlit web app URL and GitHub repository link across PPT, PDF reports and README
</commit_message>
<xml_diff>
--- a/reports/FraudLens_AI_Presentation.pptx
+++ b/reports/FraudLens_AI_Presentation.pptx
@@ -4265,6 +4265,18 @@
               <a:t>Presenter: Manish Patil | Course: Machine Learning (PBL 100 Marks)</a:t>
             </a:r>
           </a:p>
+          <a:p>
+            <a:pPr>
+              <a:defRPr sz="1200" b="1">
+                <a:solidFill>
+                  <a:srgbClr val="38BDF8"/>
+                </a:solidFill>
+              </a:defRPr>
+            </a:pPr>
+            <a:r>
+              <a:t>🌐 Live Web App: https://fraudlensai1.streamlit.app/ | 💻 GitHub: https://github.com/Manish-Patil33/FraudLens-Al-</a:t>
+            </a:r>
+          </a:p>
         </p:txBody>
       </p:sp>
     </p:spTree>
@@ -4431,6 +4443,21 @@
             </a:pPr>
             <a:r>
               <a:t>✔ Measurable Financial Value: $1.56M saved on test stream with 100% fraud recall and 0% false positives.</a:t>
+            </a:r>
+          </a:p>
+          <a:p>
+            <a:pPr>
+              <a:spcAft>
+                <a:spcPts val="800"/>
+              </a:spcAft>
+              <a:defRPr sz="1400">
+                <a:solidFill>
+                  <a:srgbClr val="E2E8F0"/>
+                </a:solidFill>
+              </a:defRPr>
+            </a:pPr>
+            <a:r>
+              <a:t>✔ Live Production Deployment: https://fraudlensai1.streamlit.app/</a:t>
             </a:r>
           </a:p>
           <a:p>
@@ -5770,7 +5797,7 @@
               </a:defRPr>
             </a:pPr>
             <a:r>
-              <a:t>• Production Web Dashboard: Built with Streamlit (app.py) for real-time risk intelligence operations.</a:t>
+              <a:t>• Production Web Dashboard: Live deployed on Streamlit Cloud at https://fraudlensai1.streamlit.app/ for real-time risk intelligence operations.</a:t>
             </a:r>
           </a:p>
           <a:p>
@@ -5831,6 +5858,21 @@
             </a:pPr>
             <a:r>
               <a:t>• Model Evaluation Lab: Interactive algorithm comparison leaderboard, ROC curves, and Precision-Recall plots.</a:t>
+            </a:r>
+          </a:p>
+          <a:p>
+            <a:pPr>
+              <a:spcAft>
+                <a:spcPts val="1400"/>
+              </a:spcAft>
+              <a:defRPr sz="1400">
+                <a:solidFill>
+                  <a:srgbClr val="1E293B"/>
+                </a:solidFill>
+              </a:defRPr>
+            </a:pPr>
+            <a:r>
+              <a:t>• Public Source Code: Open-source GitHub repository available at https://github.com/Manish-Patil33/FraudLens-Al-</a:t>
             </a:r>
           </a:p>
         </p:txBody>

</xml_diff>